<commit_message>
docs(showcase): refresh verified demo package
</commit_message>
<xml_diff>
--- a/docs/showcase/presentation/CipherPool-Presentation.pptx
+++ b/docs/showcase/presentation/CipherPool-Presentation.pptx
@@ -4634,11 +4634,11 @@
                 </a:solidFill>
                 <a:latin typeface="Liberation Mono"/>
               </a:rPr>
-              <a:t>0x105C5786
-0b32a37F
-3C7CF2AE
-cF5a39Ab
-bCA1d265</a:t>
+              <a:t>0xE47eF44E
+BB804A50
+7173BEFa
+5beb2325
+aA7451AD</a:t>
             </a:r>
           </a:p>
         </p:txBody>
@@ -6402,8 +6402,8 @@
                 </a:solidFill>
                 <a:latin typeface="Liberation Sans"/>
               </a:rPr>
-              <a:t>• Deposited testnet USDC
-• Contract and vault bindings
+              <a:t>• Deposited testnet cUSDC
+• Contract and custody bindings
 • Transaction receipts
 • Aggregate solvency</a:t>
             </a:r>
@@ -7059,7 +7059,7 @@
         <p:spPr>
           <a:xfrm>
             <a:off x="640080" y="2331720"/>
-            <a:ext cx="1600200" cy="2606040"/>
+            <a:ext cx="1828800" cy="1600200"/>
           </a:xfrm>
           <a:prstGeom prst="roundRect">
             <a:avLst/>
@@ -7103,7 +7103,7 @@
         </p:nvSpPr>
         <p:spPr>
           <a:xfrm>
-            <a:off x="822959" y="2578608"/>
+            <a:off x="804671" y="2514600"/>
             <a:ext cx="502920" cy="292608"/>
           </a:xfrm>
           <a:prstGeom prst="roundRect">
@@ -7148,7 +7148,7 @@
         </p:nvSpPr>
         <p:spPr>
           <a:xfrm>
-            <a:off x="896111" y="2596896"/>
+            <a:off x="877823" y="2532888"/>
             <a:ext cx="356616" cy="219456"/>
           </a:xfrm>
           <a:prstGeom prst="rect">
@@ -7187,8 +7187,8 @@
         </p:nvSpPr>
         <p:spPr>
           <a:xfrm>
-            <a:off x="822959" y="3108960"/>
-            <a:ext cx="1234440" cy="566928"/>
+            <a:off x="804671" y="2953512"/>
+            <a:ext cx="1499616" cy="347472"/>
           </a:xfrm>
           <a:prstGeom prst="rect">
             <a:avLst/>
@@ -7207,7 +7207,7 @@
               </a:lnSpc>
             </a:pPr>
             <a:r>
-              <a:rPr sz="1400" b="1">
+              <a:rPr sz="1300" b="1">
                 <a:solidFill>
                   <a:srgbClr val="141F37"/>
                 </a:solidFill>
@@ -7226,8 +7226,8 @@
         </p:nvSpPr>
         <p:spPr>
           <a:xfrm>
-            <a:off x="822959" y="3877056"/>
-            <a:ext cx="1234440" cy="685800"/>
+            <a:off x="804671" y="3355848"/>
+            <a:ext cx="1499616" cy="438912"/>
           </a:xfrm>
           <a:prstGeom prst="rect">
             <a:avLst/>
@@ -7242,57 +7242,67 @@
           <a:p>
             <a:pPr algn="l">
               <a:lnSpc>
-                <a:spcPct val="115000"/>
-              </a:lnSpc>
-            </a:pPr>
-            <a:r>
-              <a:rPr sz="1000" b="0">
+                <a:spcPct val="110000"/>
+              </a:lnSpc>
+            </a:pPr>
+            <a:r>
+              <a:rPr sz="900" b="0">
                 <a:solidFill>
                   <a:srgbClr val="5D6E8E"/>
                 </a:solidFill>
                 <a:latin typeface="Liberation Sans"/>
               </a:rPr>
-              <a:t>Vercel
-Wallet signatures</a:t>
-            </a:r>
-          </a:p>
-        </p:txBody>
-      </p:sp>
-      <p:cxnSp>
-        <p:nvCxnSpPr>
-          <p:cNvPr id="15" name="Connector 14"/>
-          <p:cNvCxnSpPr/>
-          <p:nvPr/>
-        </p:nvCxnSpPr>
-        <p:spPr>
-          <a:xfrm>
-            <a:off x="2240280" y="3611880"/>
-            <a:ext cx="731520" cy="0"/>
-          </a:xfrm>
-          <a:prstGeom prst="line">
-            <a:avLst/>
-          </a:prstGeom>
-          <a:ln w="25400">
+              <a:t>Encrypts input
+Requests wallet signature</a:t>
+            </a:r>
+          </a:p>
+        </p:txBody>
+      </p:sp>
+      <p:sp>
+        <p:nvSpPr>
+          <p:cNvPr id="15" name="Rounded Rectangle 14"/>
+          <p:cNvSpPr/>
+          <p:nvPr/>
+        </p:nvSpPr>
+        <p:spPr>
+          <a:xfrm>
+            <a:off x="2971800" y="2331720"/>
+            <a:ext cx="1828800" cy="1600200"/>
+          </a:xfrm>
+          <a:prstGeom prst="roundRect">
+            <a:avLst/>
+          </a:prstGeom>
+          <a:solidFill>
+            <a:srgbClr val="FFFFFF"/>
+          </a:solidFill>
+          <a:ln w="12700">
             <a:solidFill>
-              <a:srgbClr val="3157F6"/>
+              <a:srgbClr val="CFD9F1"/>
             </a:solidFill>
           </a:ln>
         </p:spPr>
         <p:style>
-          <a:lnRef idx="2">
+          <a:lnRef idx="1">
             <a:schemeClr val="accent1"/>
           </a:lnRef>
-          <a:fillRef idx="0">
+          <a:fillRef idx="3">
             <a:schemeClr val="accent1"/>
           </a:fillRef>
-          <a:effectRef idx="1">
+          <a:effectRef idx="2">
             <a:schemeClr val="accent1"/>
           </a:effectRef>
           <a:fontRef idx="minor">
-            <a:schemeClr val="tx1"/>
+            <a:schemeClr val="lt1"/>
           </a:fontRef>
         </p:style>
-      </p:cxnSp>
+        <p:txBody>
+          <a:bodyPr rtlCol="0" anchor="ctr"/>
+          <a:lstStyle/>
+          <a:p>
+            <a:pPr algn="ctr"/>
+          </a:p>
+        </p:txBody>
+      </p:sp>
       <p:sp>
         <p:nvSpPr>
           <p:cNvPr id="16" name="Rounded Rectangle 15"/>
@@ -7301,8 +7311,171 @@
         </p:nvSpPr>
         <p:spPr>
           <a:xfrm>
-            <a:off x="2971800" y="2331720"/>
-            <a:ext cx="1600200" cy="2606040"/>
+            <a:off x="3136392" y="2514600"/>
+            <a:ext cx="502920" cy="292608"/>
+          </a:xfrm>
+          <a:prstGeom prst="roundRect">
+            <a:avLst/>
+          </a:prstGeom>
+          <a:solidFill>
+            <a:srgbClr val="EFF3FF"/>
+          </a:solidFill>
+          <a:ln w="12700">
+            <a:solidFill>
+              <a:srgbClr val="EFF3FF"/>
+            </a:solidFill>
+          </a:ln>
+        </p:spPr>
+        <p:style>
+          <a:lnRef idx="1">
+            <a:schemeClr val="accent1"/>
+          </a:lnRef>
+          <a:fillRef idx="3">
+            <a:schemeClr val="accent1"/>
+          </a:fillRef>
+          <a:effectRef idx="2">
+            <a:schemeClr val="accent1"/>
+          </a:effectRef>
+          <a:fontRef idx="minor">
+            <a:schemeClr val="lt1"/>
+          </a:fontRef>
+        </p:style>
+        <p:txBody>
+          <a:bodyPr rtlCol="0" anchor="ctr"/>
+          <a:lstStyle/>
+          <a:p>
+            <a:pPr algn="ctr"/>
+          </a:p>
+        </p:txBody>
+      </p:sp>
+      <p:sp>
+        <p:nvSpPr>
+          <p:cNvPr id="17" name="TextBox 16"/>
+          <p:cNvSpPr txBox="1"/>
+          <p:nvPr/>
+        </p:nvSpPr>
+        <p:spPr>
+          <a:xfrm>
+            <a:off x="3209544" y="2532888"/>
+            <a:ext cx="356616" cy="219456"/>
+          </a:xfrm>
+          <a:prstGeom prst="rect">
+            <a:avLst/>
+          </a:prstGeom>
+          <a:noFill/>
+        </p:spPr>
+        <p:txBody>
+          <a:bodyPr wrap="none" lIns="18288" rIns="18288" tIns="18288" bIns="18288" anchor="ctr">
+            <a:spAutoFit/>
+          </a:bodyPr>
+          <a:lstStyle/>
+          <a:p>
+            <a:pPr algn="l">
+              <a:lnSpc>
+                <a:spcPct val="100000"/>
+              </a:lnSpc>
+            </a:pPr>
+            <a:r>
+              <a:rPr sz="800" b="1">
+                <a:solidFill>
+                  <a:srgbClr val="3157F6"/>
+                </a:solidFill>
+                <a:latin typeface="Liberation Sans"/>
+              </a:rPr>
+              <a:t>02</a:t>
+            </a:r>
+          </a:p>
+        </p:txBody>
+      </p:sp>
+      <p:sp>
+        <p:nvSpPr>
+          <p:cNvPr id="18" name="TextBox 17"/>
+          <p:cNvSpPr txBox="1"/>
+          <p:nvPr/>
+        </p:nvSpPr>
+        <p:spPr>
+          <a:xfrm>
+            <a:off x="3136392" y="2953512"/>
+            <a:ext cx="1499616" cy="347472"/>
+          </a:xfrm>
+          <a:prstGeom prst="rect">
+            <a:avLst/>
+          </a:prstGeom>
+          <a:noFill/>
+        </p:spPr>
+        <p:txBody>
+          <a:bodyPr wrap="none" lIns="18288" rIns="18288" tIns="18288" bIns="18288" anchor="t">
+            <a:spAutoFit/>
+          </a:bodyPr>
+          <a:lstStyle/>
+          <a:p>
+            <a:pPr algn="l">
+              <a:lnSpc>
+                <a:spcPct val="100000"/>
+              </a:lnSpc>
+            </a:pPr>
+            <a:r>
+              <a:rPr sz="1300" b="1">
+                <a:solidFill>
+                  <a:srgbClr val="141F37"/>
+                </a:solidFill>
+                <a:latin typeface="Liberation Sans"/>
+              </a:rPr>
+              <a:t>Official cUSDC</a:t>
+            </a:r>
+          </a:p>
+        </p:txBody>
+      </p:sp>
+      <p:sp>
+        <p:nvSpPr>
+          <p:cNvPr id="19" name="TextBox 18"/>
+          <p:cNvSpPr txBox="1"/>
+          <p:nvPr/>
+        </p:nvSpPr>
+        <p:spPr>
+          <a:xfrm>
+            <a:off x="3136392" y="3355848"/>
+            <a:ext cx="1499616" cy="438912"/>
+          </a:xfrm>
+          <a:prstGeom prst="rect">
+            <a:avLst/>
+          </a:prstGeom>
+          <a:noFill/>
+        </p:spPr>
+        <p:txBody>
+          <a:bodyPr wrap="none" lIns="18288" rIns="18288" tIns="18288" bIns="18288" anchor="t">
+            <a:spAutoFit/>
+          </a:bodyPr>
+          <a:lstStyle/>
+          <a:p>
+            <a:pPr algn="l">
+              <a:lnSpc>
+                <a:spcPct val="110000"/>
+              </a:lnSpc>
+            </a:pPr>
+            <a:r>
+              <a:rPr sz="900" b="0">
+                <a:solidFill>
+                  <a:srgbClr val="5D6E8E"/>
+                </a:solidFill>
+                <a:latin typeface="Liberation Sans"/>
+              </a:rPr>
+              <a:t>Moves encrypted assets
+Returns actual transfer</a:t>
+            </a:r>
+          </a:p>
+        </p:txBody>
+      </p:sp>
+      <p:sp>
+        <p:nvSpPr>
+          <p:cNvPr id="20" name="Rounded Rectangle 19"/>
+          <p:cNvSpPr/>
+          <p:nvPr/>
+        </p:nvSpPr>
+        <p:spPr>
+          <a:xfrm>
+            <a:off x="5303520" y="2331720"/>
+            <a:ext cx="2011680" cy="1600200"/>
           </a:xfrm>
           <a:prstGeom prst="roundRect">
             <a:avLst/>
@@ -7340,13 +7513,13 @@
       </p:sp>
       <p:sp>
         <p:nvSpPr>
-          <p:cNvPr id="17" name="Rounded Rectangle 16"/>
+          <p:cNvPr id="21" name="Rounded Rectangle 20"/>
           <p:cNvSpPr/>
           <p:nvPr/>
         </p:nvSpPr>
         <p:spPr>
           <a:xfrm>
-            <a:off x="3154680" y="2578608"/>
+            <a:off x="5468112" y="2514600"/>
             <a:ext cx="502920" cy="292608"/>
           </a:xfrm>
           <a:prstGeom prst="roundRect">
@@ -7385,13 +7558,13 @@
       </p:sp>
       <p:sp>
         <p:nvSpPr>
-          <p:cNvPr id="18" name="TextBox 17"/>
-          <p:cNvSpPr txBox="1"/>
-          <p:nvPr/>
-        </p:nvSpPr>
-        <p:spPr>
-          <a:xfrm>
-            <a:off x="3227832" y="2596896"/>
+          <p:cNvPr id="22" name="TextBox 21"/>
+          <p:cNvSpPr txBox="1"/>
+          <p:nvPr/>
+        </p:nvSpPr>
+        <p:spPr>
+          <a:xfrm>
+            <a:off x="5541264" y="2532888"/>
             <a:ext cx="356616" cy="219456"/>
           </a:xfrm>
           <a:prstGeom prst="rect">
@@ -7417,21 +7590,21 @@
                 </a:solidFill>
                 <a:latin typeface="Liberation Sans"/>
               </a:rPr>
-              <a:t>02</a:t>
-            </a:r>
-          </a:p>
-        </p:txBody>
-      </p:sp>
-      <p:sp>
-        <p:nvSpPr>
-          <p:cNvPr id="19" name="TextBox 18"/>
-          <p:cNvSpPr txBox="1"/>
-          <p:nvPr/>
-        </p:nvSpPr>
-        <p:spPr>
-          <a:xfrm>
-            <a:off x="3154680" y="3108960"/>
-            <a:ext cx="1234440" cy="566928"/>
+              <a:t>03</a:t>
+            </a:r>
+          </a:p>
+        </p:txBody>
+      </p:sp>
+      <p:sp>
+        <p:nvSpPr>
+          <p:cNvPr id="23" name="TextBox 22"/>
+          <p:cNvSpPr txBox="1"/>
+          <p:nvPr/>
+        </p:nvSpPr>
+        <p:spPr>
+          <a:xfrm>
+            <a:off x="5468112" y="2953512"/>
+            <a:ext cx="1682496" cy="347472"/>
           </a:xfrm>
           <a:prstGeom prst="rect">
             <a:avLst/>
@@ -7450,7 +7623,7 @@
               </a:lnSpc>
             </a:pPr>
             <a:r>
-              <a:rPr sz="1400" b="1">
+              <a:rPr sz="1300" b="1">
                 <a:solidFill>
                   <a:srgbClr val="141F37"/>
                 </a:solidFill>
@@ -7463,14 +7636,14 @@
       </p:sp>
       <p:sp>
         <p:nvSpPr>
-          <p:cNvPr id="20" name="TextBox 19"/>
-          <p:cNvSpPr txBox="1"/>
-          <p:nvPr/>
-        </p:nvSpPr>
-        <p:spPr>
-          <a:xfrm>
-            <a:off x="3154680" y="3877056"/>
-            <a:ext cx="1234440" cy="685800"/>
+          <p:cNvPr id="24" name="TextBox 23"/>
+          <p:cNvSpPr txBox="1"/>
+          <p:nvPr/>
+        </p:nvSpPr>
+        <p:spPr>
+          <a:xfrm>
+            <a:off x="5468112" y="3355848"/>
+            <a:ext cx="1682496" cy="438912"/>
           </a:xfrm>
           <a:prstGeom prst="rect">
             <a:avLst/>
@@ -7485,67 +7658,240 @@
           <a:p>
             <a:pPr algn="l">
               <a:lnSpc>
-                <a:spcPct val="115000"/>
-              </a:lnSpc>
-            </a:pPr>
-            <a:r>
-              <a:rPr sz="1000" b="0">
+                <a:spcPct val="110000"/>
+              </a:lnSpc>
+            </a:pPr>
+            <a:r>
+              <a:rPr sz="900" b="0">
                 <a:solidFill>
                   <a:srgbClr val="5D6E8E"/>
                 </a:solidFill>
                 <a:latin typeface="Liberation Sans"/>
               </a:rPr>
-              <a:t>Encrypted balances
-Prize liabilities</a:t>
-            </a:r>
-          </a:p>
-        </p:txBody>
-      </p:sp>
-      <p:cxnSp>
-        <p:nvCxnSpPr>
-          <p:cNvPr id="21" name="Connector 20"/>
-          <p:cNvCxnSpPr/>
-          <p:nvPr/>
-        </p:nvCxnSpPr>
-        <p:spPr>
-          <a:xfrm>
-            <a:off x="4572000" y="3611880"/>
-            <a:ext cx="731520" cy="0"/>
-          </a:xfrm>
-          <a:prstGeom prst="line">
-            <a:avLst/>
-          </a:prstGeom>
-          <a:ln w="25400">
+              <a:t>Owns encrypted positions
+Reserve + draw state</a:t>
+            </a:r>
+          </a:p>
+        </p:txBody>
+      </p:sp>
+      <p:sp>
+        <p:nvSpPr>
+          <p:cNvPr id="25" name="Rounded Rectangle 24"/>
+          <p:cNvSpPr/>
+          <p:nvPr/>
+        </p:nvSpPr>
+        <p:spPr>
+          <a:xfrm>
+            <a:off x="8229600" y="2331720"/>
+            <a:ext cx="2240280" cy="1600200"/>
+          </a:xfrm>
+          <a:prstGeom prst="roundRect">
+            <a:avLst/>
+          </a:prstGeom>
+          <a:solidFill>
+            <a:srgbClr val="EFF3FF"/>
+          </a:solidFill>
+          <a:ln w="12700">
             <a:solidFill>
-              <a:srgbClr val="3157F6"/>
+              <a:srgbClr val="CFD9F1"/>
             </a:solidFill>
           </a:ln>
         </p:spPr>
         <p:style>
-          <a:lnRef idx="2">
+          <a:lnRef idx="1">
             <a:schemeClr val="accent1"/>
           </a:lnRef>
-          <a:fillRef idx="0">
+          <a:fillRef idx="3">
             <a:schemeClr val="accent1"/>
           </a:fillRef>
-          <a:effectRef idx="1">
+          <a:effectRef idx="2">
             <a:schemeClr val="accent1"/>
           </a:effectRef>
           <a:fontRef idx="minor">
-            <a:schemeClr val="tx1"/>
+            <a:schemeClr val="lt1"/>
           </a:fontRef>
         </p:style>
-      </p:cxnSp>
-      <p:sp>
-        <p:nvSpPr>
-          <p:cNvPr id="22" name="Rounded Rectangle 21"/>
+        <p:txBody>
+          <a:bodyPr rtlCol="0" anchor="ctr"/>
+          <a:lstStyle/>
+          <a:p>
+            <a:pPr algn="ctr"/>
+          </a:p>
+        </p:txBody>
+      </p:sp>
+      <p:sp>
+        <p:nvSpPr>
+          <p:cNvPr id="26" name="Rounded Rectangle 25"/>
           <p:cNvSpPr/>
           <p:nvPr/>
         </p:nvSpPr>
         <p:spPr>
           <a:xfrm>
-            <a:off x="5303520" y="2331720"/>
-            <a:ext cx="1600200" cy="2606040"/>
+            <a:off x="8394192" y="2514600"/>
+            <a:ext cx="502920" cy="292608"/>
+          </a:xfrm>
+          <a:prstGeom prst="roundRect">
+            <a:avLst/>
+          </a:prstGeom>
+          <a:solidFill>
+            <a:srgbClr val="EFF3FF"/>
+          </a:solidFill>
+          <a:ln w="12700">
+            <a:solidFill>
+              <a:srgbClr val="EFF3FF"/>
+            </a:solidFill>
+          </a:ln>
+        </p:spPr>
+        <p:style>
+          <a:lnRef idx="1">
+            <a:schemeClr val="accent1"/>
+          </a:lnRef>
+          <a:fillRef idx="3">
+            <a:schemeClr val="accent1"/>
+          </a:fillRef>
+          <a:effectRef idx="2">
+            <a:schemeClr val="accent1"/>
+          </a:effectRef>
+          <a:fontRef idx="minor">
+            <a:schemeClr val="lt1"/>
+          </a:fontRef>
+        </p:style>
+        <p:txBody>
+          <a:bodyPr rtlCol="0" anchor="ctr"/>
+          <a:lstStyle/>
+          <a:p>
+            <a:pPr algn="ctr"/>
+          </a:p>
+        </p:txBody>
+      </p:sp>
+      <p:sp>
+        <p:nvSpPr>
+          <p:cNvPr id="27" name="TextBox 26"/>
+          <p:cNvSpPr txBox="1"/>
+          <p:nvPr/>
+        </p:nvSpPr>
+        <p:spPr>
+          <a:xfrm>
+            <a:off x="8467344" y="2532888"/>
+            <a:ext cx="356616" cy="219456"/>
+          </a:xfrm>
+          <a:prstGeom prst="rect">
+            <a:avLst/>
+          </a:prstGeom>
+          <a:noFill/>
+        </p:spPr>
+        <p:txBody>
+          <a:bodyPr wrap="none" lIns="18288" rIns="18288" tIns="18288" bIns="18288" anchor="ctr">
+            <a:spAutoFit/>
+          </a:bodyPr>
+          <a:lstStyle/>
+          <a:p>
+            <a:pPr algn="l">
+              <a:lnSpc>
+                <a:spcPct val="100000"/>
+              </a:lnSpc>
+            </a:pPr>
+            <a:r>
+              <a:rPr sz="800" b="1">
+                <a:solidFill>
+                  <a:srgbClr val="3157F6"/>
+                </a:solidFill>
+                <a:latin typeface="Liberation Sans"/>
+              </a:rPr>
+              <a:t>04</a:t>
+            </a:r>
+          </a:p>
+        </p:txBody>
+      </p:sp>
+      <p:sp>
+        <p:nvSpPr>
+          <p:cNvPr id="28" name="TextBox 27"/>
+          <p:cNvSpPr txBox="1"/>
+          <p:nvPr/>
+        </p:nvSpPr>
+        <p:spPr>
+          <a:xfrm>
+            <a:off x="8394192" y="2953512"/>
+            <a:ext cx="1911096" cy="347472"/>
+          </a:xfrm>
+          <a:prstGeom prst="rect">
+            <a:avLst/>
+          </a:prstGeom>
+          <a:noFill/>
+        </p:spPr>
+        <p:txBody>
+          <a:bodyPr wrap="none" lIns="18288" rIns="18288" tIns="18288" bIns="18288" anchor="t">
+            <a:spAutoFit/>
+          </a:bodyPr>
+          <a:lstStyle/>
+          <a:p>
+            <a:pPr algn="l">
+              <a:lnSpc>
+                <a:spcPct val="100000"/>
+              </a:lnSpc>
+            </a:pPr>
+            <a:r>
+              <a:rPr sz="1300" b="1">
+                <a:solidFill>
+                  <a:srgbClr val="141F37"/>
+                </a:solidFill>
+                <a:latin typeface="Liberation Sans"/>
+              </a:rPr>
+              <a:t>Zama relayer + KMS</a:t>
+            </a:r>
+          </a:p>
+        </p:txBody>
+      </p:sp>
+      <p:sp>
+        <p:nvSpPr>
+          <p:cNvPr id="29" name="TextBox 28"/>
+          <p:cNvSpPr txBox="1"/>
+          <p:nvPr/>
+        </p:nvSpPr>
+        <p:spPr>
+          <a:xfrm>
+            <a:off x="8394192" y="3355848"/>
+            <a:ext cx="1911096" cy="438912"/>
+          </a:xfrm>
+          <a:prstGeom prst="rect">
+            <a:avLst/>
+          </a:prstGeom>
+          <a:noFill/>
+        </p:spPr>
+        <p:txBody>
+          <a:bodyPr wrap="none" lIns="18288" rIns="18288" tIns="18288" bIns="18288" anchor="t">
+            <a:spAutoFit/>
+          </a:bodyPr>
+          <a:lstStyle/>
+          <a:p>
+            <a:pPr algn="l">
+              <a:lnSpc>
+                <a:spcPct val="110000"/>
+              </a:lnSpc>
+            </a:pPr>
+            <a:r>
+              <a:rPr sz="900" b="0">
+                <a:solidFill>
+                  <a:srgbClr val="5D6E8E"/>
+                </a:solidFill>
+                <a:latin typeface="Liberation Sans"/>
+              </a:rPr>
+              <a:t>Prepares authorized proofs
+Verifies public snapshots</a:t>
+            </a:r>
+          </a:p>
+        </p:txBody>
+      </p:sp>
+      <p:sp>
+        <p:nvSpPr>
+          <p:cNvPr id="30" name="Rounded Rectangle 29"/>
+          <p:cNvSpPr/>
+          <p:nvPr/>
+        </p:nvSpPr>
+        <p:spPr>
+          <a:xfrm>
+            <a:off x="5303520" y="4800600"/>
+            <a:ext cx="2011680" cy="1600200"/>
           </a:xfrm>
           <a:prstGeom prst="roundRect">
             <a:avLst/>
@@ -7583,13 +7929,13 @@
       </p:sp>
       <p:sp>
         <p:nvSpPr>
-          <p:cNvPr id="23" name="Rounded Rectangle 22"/>
+          <p:cNvPr id="31" name="Rounded Rectangle 30"/>
           <p:cNvSpPr/>
           <p:nvPr/>
         </p:nvSpPr>
         <p:spPr>
           <a:xfrm>
-            <a:off x="5486400" y="2578608"/>
+            <a:off x="5468112" y="4983480"/>
             <a:ext cx="502920" cy="292608"/>
           </a:xfrm>
           <a:prstGeom prst="roundRect">
@@ -7628,13 +7974,13 @@
       </p:sp>
       <p:sp>
         <p:nvSpPr>
-          <p:cNvPr id="24" name="TextBox 23"/>
-          <p:cNvSpPr txBox="1"/>
-          <p:nvPr/>
-        </p:nvSpPr>
-        <p:spPr>
-          <a:xfrm>
-            <a:off x="5559552" y="2596896"/>
+          <p:cNvPr id="32" name="TextBox 31"/>
+          <p:cNvSpPr txBox="1"/>
+          <p:nvPr/>
+        </p:nvSpPr>
+        <p:spPr>
+          <a:xfrm>
+            <a:off x="5541264" y="5001768"/>
             <a:ext cx="356616" cy="219456"/>
           </a:xfrm>
           <a:prstGeom prst="rect">
@@ -7660,21 +8006,21 @@
                 </a:solidFill>
                 <a:latin typeface="Liberation Sans"/>
               </a:rPr>
-              <a:t>03</a:t>
-            </a:r>
-          </a:p>
-        </p:txBody>
-      </p:sp>
-      <p:sp>
-        <p:nvSpPr>
-          <p:cNvPr id="25" name="TextBox 24"/>
-          <p:cNvSpPr txBox="1"/>
-          <p:nvPr/>
-        </p:nvSpPr>
-        <p:spPr>
-          <a:xfrm>
-            <a:off x="5486400" y="3108960"/>
-            <a:ext cx="1234440" cy="566928"/>
+              <a:t>05</a:t>
+            </a:r>
+          </a:p>
+        </p:txBody>
+      </p:sp>
+      <p:sp>
+        <p:nvSpPr>
+          <p:cNvPr id="33" name="TextBox 32"/>
+          <p:cNvSpPr txBox="1"/>
+          <p:nvPr/>
+        </p:nvSpPr>
+        <p:spPr>
+          <a:xfrm>
+            <a:off x="5468112" y="5422392"/>
+            <a:ext cx="1682496" cy="347472"/>
           </a:xfrm>
           <a:prstGeom prst="rect">
             <a:avLst/>
@@ -7693,27 +8039,27 @@
               </a:lnSpc>
             </a:pPr>
             <a:r>
-              <a:rPr sz="1400" b="1">
+              <a:rPr sz="1300" b="1">
                 <a:solidFill>
                   <a:srgbClr val="141F37"/>
                 </a:solidFill>
                 <a:latin typeface="Liberation Sans"/>
               </a:rPr>
-              <a:t>ConfidentialVault</a:t>
-            </a:r>
-          </a:p>
-        </p:txBody>
-      </p:sp>
-      <p:sp>
-        <p:nvSpPr>
-          <p:cNvPr id="26" name="TextBox 25"/>
-          <p:cNvSpPr txBox="1"/>
-          <p:nvPr/>
-        </p:nvSpPr>
-        <p:spPr>
-          <a:xfrm>
-            <a:off x="5486400" y="3877056"/>
-            <a:ext cx="1234440" cy="685800"/>
+              <a:t>Indexer + PostgreSQL</a:t>
+            </a:r>
+          </a:p>
+        </p:txBody>
+      </p:sp>
+      <p:sp>
+        <p:nvSpPr>
+          <p:cNvPr id="34" name="TextBox 33"/>
+          <p:cNvSpPr txBox="1"/>
+          <p:nvPr/>
+        </p:nvSpPr>
+        <p:spPr>
+          <a:xfrm>
+            <a:off x="5468112" y="5824728"/>
+            <a:ext cx="1682496" cy="438912"/>
           </a:xfrm>
           <a:prstGeom prst="rect">
             <a:avLst/>
@@ -7728,73 +8074,38 @@
           <a:p>
             <a:pPr algn="l">
               <a:lnSpc>
-                <a:spcPct val="115000"/>
-              </a:lnSpc>
-            </a:pPr>
-            <a:r>
-              <a:rPr sz="1000" b="0">
+                <a:spcPct val="110000"/>
+              </a:lnSpc>
+            </a:pPr>
+            <a:r>
+              <a:rPr sz="900" b="0">
                 <a:solidFill>
                   <a:srgbClr val="5D6E8E"/>
                 </a:solidFill>
                 <a:latin typeface="Liberation Sans"/>
               </a:rPr>
-              <a:t>Strategy custody
-Yield isolation</a:t>
-            </a:r>
-          </a:p>
-        </p:txBody>
-      </p:sp>
-      <p:cxnSp>
-        <p:nvCxnSpPr>
-          <p:cNvPr id="27" name="Connector 26"/>
-          <p:cNvCxnSpPr/>
-          <p:nvPr/>
-        </p:nvCxnSpPr>
-        <p:spPr>
-          <a:xfrm>
-            <a:off x="6903720" y="3611880"/>
-            <a:ext cx="731520" cy="0"/>
-          </a:xfrm>
-          <a:prstGeom prst="line">
-            <a:avLst/>
-          </a:prstGeom>
-          <a:ln w="25400">
-            <a:solidFill>
-              <a:srgbClr val="3157F6"/>
-            </a:solidFill>
-          </a:ln>
-        </p:spPr>
-        <p:style>
-          <a:lnRef idx="2">
-            <a:schemeClr val="accent1"/>
-          </a:lnRef>
-          <a:fillRef idx="0">
-            <a:schemeClr val="accent1"/>
-          </a:fillRef>
-          <a:effectRef idx="1">
-            <a:schemeClr val="accent1"/>
-          </a:effectRef>
-          <a:fontRef idx="minor">
-            <a:schemeClr val="tx1"/>
-          </a:fontRef>
-        </p:style>
-      </p:cxnSp>
-      <p:sp>
-        <p:nvSpPr>
-          <p:cNvPr id="28" name="Rounded Rectangle 27"/>
+              <a:t>Observes public events
+Persists checkpoints</a:t>
+            </a:r>
+          </a:p>
+        </p:txBody>
+      </p:sp>
+      <p:sp>
+        <p:nvSpPr>
+          <p:cNvPr id="35" name="Rounded Rectangle 34"/>
           <p:cNvSpPr/>
           <p:nvPr/>
         </p:nvSpPr>
         <p:spPr>
           <a:xfrm>
-            <a:off x="7635240" y="2331720"/>
-            <a:ext cx="1600200" cy="2606040"/>
+            <a:off x="1874519" y="4800600"/>
+            <a:ext cx="2011680" cy="1600200"/>
           </a:xfrm>
           <a:prstGeom prst="roundRect">
             <a:avLst/>
           </a:prstGeom>
           <a:solidFill>
-            <a:srgbClr val="EFF3FF"/>
+            <a:srgbClr val="FFFFFF"/>
           </a:solidFill>
           <a:ln w="12700">
             <a:solidFill>
@@ -7826,13 +8137,13 @@
       </p:sp>
       <p:sp>
         <p:nvSpPr>
-          <p:cNvPr id="29" name="Rounded Rectangle 28"/>
+          <p:cNvPr id="36" name="Rounded Rectangle 35"/>
           <p:cNvSpPr/>
           <p:nvPr/>
         </p:nvSpPr>
         <p:spPr>
           <a:xfrm>
-            <a:off x="7818119" y="2578608"/>
+            <a:off x="2039112" y="4983480"/>
             <a:ext cx="502920" cy="292608"/>
           </a:xfrm>
           <a:prstGeom prst="roundRect">
@@ -7871,13 +8182,13 @@
       </p:sp>
       <p:sp>
         <p:nvSpPr>
-          <p:cNvPr id="30" name="TextBox 29"/>
-          <p:cNvSpPr txBox="1"/>
-          <p:nvPr/>
-        </p:nvSpPr>
-        <p:spPr>
-          <a:xfrm>
-            <a:off x="7891271" y="2596896"/>
+          <p:cNvPr id="37" name="TextBox 36"/>
+          <p:cNvSpPr txBox="1"/>
+          <p:nvPr/>
+        </p:nvSpPr>
+        <p:spPr>
+          <a:xfrm>
+            <a:off x="2112264" y="5001768"/>
             <a:ext cx="356616" cy="219456"/>
           </a:xfrm>
           <a:prstGeom prst="rect">
@@ -7903,21 +8214,21 @@
                 </a:solidFill>
                 <a:latin typeface="Liberation Sans"/>
               </a:rPr>
-              <a:t>04</a:t>
-            </a:r>
-          </a:p>
-        </p:txBody>
-      </p:sp>
-      <p:sp>
-        <p:nvSpPr>
-          <p:cNvPr id="31" name="TextBox 30"/>
-          <p:cNvSpPr txBox="1"/>
-          <p:nvPr/>
-        </p:nvSpPr>
-        <p:spPr>
-          <a:xfrm>
-            <a:off x="7818119" y="3108960"/>
-            <a:ext cx="1234440" cy="566928"/>
+              <a:t>IN</a:t>
+            </a:r>
+          </a:p>
+        </p:txBody>
+      </p:sp>
+      <p:sp>
+        <p:nvSpPr>
+          <p:cNvPr id="38" name="TextBox 37"/>
+          <p:cNvSpPr txBox="1"/>
+          <p:nvPr/>
+        </p:nvSpPr>
+        <p:spPr>
+          <a:xfrm>
+            <a:off x="2039112" y="5422392"/>
+            <a:ext cx="1682496" cy="347472"/>
           </a:xfrm>
           <a:prstGeom prst="rect">
             <a:avLst/>
@@ -7936,27 +8247,27 @@
               </a:lnSpc>
             </a:pPr>
             <a:r>
-              <a:rPr sz="1400" b="1">
+              <a:rPr sz="1300" b="1">
                 <a:solidFill>
                   <a:srgbClr val="141F37"/>
                 </a:solidFill>
                 <a:latin typeface="Liberation Sans"/>
               </a:rPr>
-              <a:t>Zama relayer + KMS</a:t>
-            </a:r>
-          </a:p>
-        </p:txBody>
-      </p:sp>
-      <p:sp>
-        <p:nvSpPr>
-          <p:cNvPr id="32" name="TextBox 31"/>
-          <p:cNvSpPr txBox="1"/>
-          <p:nvPr/>
-        </p:nvSpPr>
-        <p:spPr>
-          <a:xfrm>
-            <a:off x="7818119" y="3877056"/>
-            <a:ext cx="1234440" cy="685800"/>
+              <a:t>Sponsor wallet</a:t>
+            </a:r>
+          </a:p>
+        </p:txBody>
+      </p:sp>
+      <p:sp>
+        <p:nvSpPr>
+          <p:cNvPr id="39" name="TextBox 38"/>
+          <p:cNvSpPr txBox="1"/>
+          <p:nvPr/>
+        </p:nvSpPr>
+        <p:spPr>
+          <a:xfrm>
+            <a:off x="2039112" y="5824728"/>
+            <a:ext cx="1682496" cy="438912"/>
           </a:xfrm>
           <a:prstGeom prst="rect">
             <a:avLst/>
@@ -7971,32 +8282,32 @@
           <a:p>
             <a:pPr algn="l">
               <a:lnSpc>
-                <a:spcPct val="115000"/>
-              </a:lnSpc>
-            </a:pPr>
-            <a:r>
-              <a:rPr sz="1000" b="0">
+                <a:spcPct val="110000"/>
+              </a:lnSpc>
+            </a:pPr>
+            <a:r>
+              <a:rPr sz="900" b="0">
                 <a:solidFill>
                   <a:srgbClr val="5D6E8E"/>
                 </a:solidFill>
                 <a:latin typeface="Liberation Sans"/>
               </a:rPr>
-              <a:t>Threshold proof
-Public decryption</a:t>
+              <a:t>Transfers encrypted cUSDC
+into the prize reserve</a:t>
             </a:r>
           </a:p>
         </p:txBody>
       </p:sp>
       <p:cxnSp>
         <p:nvCxnSpPr>
-          <p:cNvPr id="33" name="Connector 32"/>
+          <p:cNvPr id="40" name="Connector 39"/>
           <p:cNvCxnSpPr/>
           <p:nvPr/>
         </p:nvCxnSpPr>
         <p:spPr>
           <a:xfrm>
-            <a:off x="9235440" y="3611880"/>
-            <a:ext cx="731519" cy="0"/>
+            <a:off x="2468880" y="3127248"/>
+            <a:ext cx="502920" cy="0"/>
           </a:xfrm>
           <a:prstGeom prst="line">
             <a:avLst/>
@@ -8022,224 +8333,156 @@
           </a:fontRef>
         </p:style>
       </p:cxnSp>
-      <p:sp>
-        <p:nvSpPr>
-          <p:cNvPr id="34" name="Rounded Rectangle 33"/>
-          <p:cNvSpPr/>
-          <p:nvPr/>
-        </p:nvSpPr>
-        <p:spPr>
-          <a:xfrm>
-            <a:off x="9966960" y="2331720"/>
-            <a:ext cx="1600200" cy="2606040"/>
-          </a:xfrm>
-          <a:prstGeom prst="roundRect">
-            <a:avLst/>
-          </a:prstGeom>
-          <a:solidFill>
-            <a:srgbClr val="FFFFFF"/>
-          </a:solidFill>
-          <a:ln w="12700">
+      <p:cxnSp>
+        <p:nvCxnSpPr>
+          <p:cNvPr id="41" name="Connector 40"/>
+          <p:cNvCxnSpPr/>
+          <p:nvPr/>
+        </p:nvCxnSpPr>
+        <p:spPr>
+          <a:xfrm>
+            <a:off x="4800600" y="3127248"/>
+            <a:ext cx="502920" cy="0"/>
+          </a:xfrm>
+          <a:prstGeom prst="line">
+            <a:avLst/>
+          </a:prstGeom>
+          <a:ln w="25400">
             <a:solidFill>
-              <a:srgbClr val="CFD9F1"/>
+              <a:srgbClr val="3157F6"/>
             </a:solidFill>
           </a:ln>
         </p:spPr>
         <p:style>
-          <a:lnRef idx="1">
+          <a:lnRef idx="2">
             <a:schemeClr val="accent1"/>
           </a:lnRef>
-          <a:fillRef idx="3">
+          <a:fillRef idx="0">
             <a:schemeClr val="accent1"/>
           </a:fillRef>
-          <a:effectRef idx="2">
+          <a:effectRef idx="1">
             <a:schemeClr val="accent1"/>
           </a:effectRef>
           <a:fontRef idx="minor">
-            <a:schemeClr val="lt1"/>
+            <a:schemeClr val="tx1"/>
           </a:fontRef>
         </p:style>
-        <p:txBody>
-          <a:bodyPr rtlCol="0" anchor="ctr"/>
-          <a:lstStyle/>
-          <a:p>
-            <a:pPr algn="ctr"/>
-          </a:p>
-        </p:txBody>
-      </p:sp>
-      <p:sp>
-        <p:nvSpPr>
-          <p:cNvPr id="35" name="Rounded Rectangle 34"/>
-          <p:cNvSpPr/>
-          <p:nvPr/>
-        </p:nvSpPr>
-        <p:spPr>
-          <a:xfrm>
-            <a:off x="10149840" y="2578608"/>
-            <a:ext cx="502920" cy="292608"/>
-          </a:xfrm>
-          <a:prstGeom prst="roundRect">
-            <a:avLst/>
-          </a:prstGeom>
-          <a:solidFill>
-            <a:srgbClr val="EFF3FF"/>
-          </a:solidFill>
-          <a:ln w="12700">
+      </p:cxnSp>
+      <p:cxnSp>
+        <p:nvCxnSpPr>
+          <p:cNvPr id="42" name="Connector 41"/>
+          <p:cNvCxnSpPr/>
+          <p:nvPr/>
+        </p:nvCxnSpPr>
+        <p:spPr>
+          <a:xfrm>
+            <a:off x="7315200" y="3127248"/>
+            <a:ext cx="914400" cy="0"/>
+          </a:xfrm>
+          <a:prstGeom prst="line">
+            <a:avLst/>
+          </a:prstGeom>
+          <a:ln w="25400">
             <a:solidFill>
-              <a:srgbClr val="EFF3FF"/>
+              <a:srgbClr val="3157F6"/>
             </a:solidFill>
           </a:ln>
         </p:spPr>
         <p:style>
-          <a:lnRef idx="1">
+          <a:lnRef idx="2">
             <a:schemeClr val="accent1"/>
           </a:lnRef>
-          <a:fillRef idx="3">
+          <a:fillRef idx="0">
             <a:schemeClr val="accent1"/>
           </a:fillRef>
-          <a:effectRef idx="2">
+          <a:effectRef idx="1">
             <a:schemeClr val="accent1"/>
           </a:effectRef>
           <a:fontRef idx="minor">
-            <a:schemeClr val="lt1"/>
+            <a:schemeClr val="tx1"/>
           </a:fontRef>
         </p:style>
-        <p:txBody>
-          <a:bodyPr rtlCol="0" anchor="ctr"/>
-          <a:lstStyle/>
-          <a:p>
-            <a:pPr algn="ctr"/>
-          </a:p>
-        </p:txBody>
-      </p:sp>
-      <p:sp>
-        <p:nvSpPr>
-          <p:cNvPr id="36" name="TextBox 35"/>
-          <p:cNvSpPr txBox="1"/>
-          <p:nvPr/>
-        </p:nvSpPr>
-        <p:spPr>
-          <a:xfrm>
-            <a:off x="10222992" y="2596896"/>
-            <a:ext cx="356616" cy="219456"/>
-          </a:xfrm>
-          <a:prstGeom prst="rect">
-            <a:avLst/>
-          </a:prstGeom>
-          <a:noFill/>
-        </p:spPr>
-        <p:txBody>
-          <a:bodyPr wrap="none" lIns="18288" rIns="18288" tIns="18288" bIns="18288" anchor="ctr">
-            <a:spAutoFit/>
-          </a:bodyPr>
-          <a:lstStyle/>
-          <a:p>
-            <a:pPr algn="l">
-              <a:lnSpc>
-                <a:spcPct val="100000"/>
-              </a:lnSpc>
-            </a:pPr>
-            <a:r>
-              <a:rPr sz="800" b="1">
-                <a:solidFill>
-                  <a:srgbClr val="3157F6"/>
-                </a:solidFill>
-                <a:latin typeface="Liberation Sans"/>
-              </a:rPr>
-              <a:t>05</a:t>
-            </a:r>
-          </a:p>
-        </p:txBody>
-      </p:sp>
-      <p:sp>
-        <p:nvSpPr>
-          <p:cNvPr id="37" name="TextBox 36"/>
-          <p:cNvSpPr txBox="1"/>
-          <p:nvPr/>
-        </p:nvSpPr>
-        <p:spPr>
-          <a:xfrm>
-            <a:off x="10149840" y="3108960"/>
-            <a:ext cx="1234440" cy="566928"/>
-          </a:xfrm>
-          <a:prstGeom prst="rect">
-            <a:avLst/>
-          </a:prstGeom>
-          <a:noFill/>
-        </p:spPr>
-        <p:txBody>
-          <a:bodyPr wrap="none" lIns="18288" rIns="18288" tIns="18288" bIns="18288" anchor="t">
-            <a:spAutoFit/>
-          </a:bodyPr>
-          <a:lstStyle/>
-          <a:p>
-            <a:pPr algn="l">
-              <a:lnSpc>
-                <a:spcPct val="100000"/>
-              </a:lnSpc>
-            </a:pPr>
-            <a:r>
-              <a:rPr sz="1400" b="1">
-                <a:solidFill>
-                  <a:srgbClr val="141F37"/>
-                </a:solidFill>
-                <a:latin typeface="Liberation Sans"/>
-              </a:rPr>
-              <a:t>Indexer + PostgreSQL</a:t>
-            </a:r>
-          </a:p>
-        </p:txBody>
-      </p:sp>
-      <p:sp>
-        <p:nvSpPr>
-          <p:cNvPr id="38" name="TextBox 37"/>
-          <p:cNvSpPr txBox="1"/>
-          <p:nvPr/>
-        </p:nvSpPr>
-        <p:spPr>
-          <a:xfrm>
-            <a:off x="10149840" y="3877056"/>
-            <a:ext cx="1234440" cy="685800"/>
-          </a:xfrm>
-          <a:prstGeom prst="rect">
-            <a:avLst/>
-          </a:prstGeom>
-          <a:noFill/>
-        </p:spPr>
-        <p:txBody>
-          <a:bodyPr wrap="none" lIns="18288" rIns="18288" tIns="18288" bIns="18288" anchor="t">
-            <a:spAutoFit/>
-          </a:bodyPr>
-          <a:lstStyle/>
-          <a:p>
-            <a:pPr algn="l">
-              <a:lnSpc>
-                <a:spcPct val="115000"/>
-              </a:lnSpc>
-            </a:pPr>
-            <a:r>
-              <a:rPr sz="1000" b="0">
-                <a:solidFill>
-                  <a:srgbClr val="5D6E8E"/>
-                </a:solidFill>
-                <a:latin typeface="Liberation Sans"/>
-              </a:rPr>
-              <a:t>Public state
-Durable checkpoint</a:t>
-            </a:r>
-          </a:p>
-        </p:txBody>
-      </p:sp>
-      <p:sp>
-        <p:nvSpPr>
-          <p:cNvPr id="39" name="Rounded Rectangle 38"/>
+      </p:cxnSp>
+      <p:cxnSp>
+        <p:nvCxnSpPr>
+          <p:cNvPr id="43" name="Connector 42"/>
+          <p:cNvCxnSpPr/>
+          <p:nvPr/>
+        </p:nvCxnSpPr>
+        <p:spPr>
+          <a:xfrm>
+            <a:off x="6309360" y="3931920"/>
+            <a:ext cx="0" cy="868680"/>
+          </a:xfrm>
+          <a:prstGeom prst="line">
+            <a:avLst/>
+          </a:prstGeom>
+          <a:ln w="25400">
+            <a:solidFill>
+              <a:srgbClr val="3157F6"/>
+            </a:solidFill>
+          </a:ln>
+        </p:spPr>
+        <p:style>
+          <a:lnRef idx="2">
+            <a:schemeClr val="accent1"/>
+          </a:lnRef>
+          <a:fillRef idx="0">
+            <a:schemeClr val="accent1"/>
+          </a:fillRef>
+          <a:effectRef idx="1">
+            <a:schemeClr val="accent1"/>
+          </a:effectRef>
+          <a:fontRef idx="minor">
+            <a:schemeClr val="tx1"/>
+          </a:fontRef>
+        </p:style>
+      </p:cxnSp>
+      <p:cxnSp>
+        <p:nvCxnSpPr>
+          <p:cNvPr id="44" name="Connector 43"/>
+          <p:cNvCxnSpPr/>
+          <p:nvPr/>
+        </p:nvCxnSpPr>
+        <p:spPr>
+          <a:xfrm flipV="1">
+            <a:off x="3886200" y="3703320"/>
+            <a:ext cx="1417320" cy="1892808"/>
+          </a:xfrm>
+          <a:prstGeom prst="line">
+            <a:avLst/>
+          </a:prstGeom>
+          <a:ln w="25400">
+            <a:solidFill>
+              <a:srgbClr val="3157F6"/>
+            </a:solidFill>
+          </a:ln>
+        </p:spPr>
+        <p:style>
+          <a:lnRef idx="2">
+            <a:schemeClr val="accent1"/>
+          </a:lnRef>
+          <a:fillRef idx="0">
+            <a:schemeClr val="accent1"/>
+          </a:fillRef>
+          <a:effectRef idx="1">
+            <a:schemeClr val="accent1"/>
+          </a:effectRef>
+          <a:fontRef idx="minor">
+            <a:schemeClr val="tx1"/>
+          </a:fontRef>
+        </p:style>
+      </p:cxnSp>
+      <p:sp>
+        <p:nvSpPr>
+          <p:cNvPr id="45" name="Rounded Rectangle 44"/>
           <p:cNvSpPr/>
           <p:nvPr/>
         </p:nvSpPr>
         <p:spPr>
           <a:xfrm>
-            <a:off x="1920240" y="5303520"/>
-            <a:ext cx="8321040" cy="594360"/>
+            <a:off x="8229600" y="4800600"/>
+            <a:ext cx="2240280" cy="914400"/>
           </a:xfrm>
           <a:prstGeom prst="roundRect">
             <a:avLst/>
@@ -8277,14 +8520,14 @@
       </p:sp>
       <p:sp>
         <p:nvSpPr>
-          <p:cNvPr id="40" name="TextBox 39"/>
-          <p:cNvSpPr txBox="1"/>
-          <p:nvPr/>
-        </p:nvSpPr>
-        <p:spPr>
-          <a:xfrm>
-            <a:off x="2057400" y="5458968"/>
-            <a:ext cx="8046720" cy="274320"/>
+          <p:cNvPr id="46" name="TextBox 45"/>
+          <p:cNvSpPr txBox="1"/>
+          <p:nvPr/>
+        </p:nvSpPr>
+        <p:spPr>
+          <a:xfrm>
+            <a:off x="8394192" y="5029200"/>
+            <a:ext cx="1920240" cy="457200"/>
           </a:xfrm>
           <a:prstGeom prst="rect">
             <a:avLst/>
@@ -8299,24 +8542,25 @@
           <a:p>
             <a:pPr algn="ctr">
               <a:lnSpc>
-                <a:spcPct val="100000"/>
-              </a:lnSpc>
-            </a:pPr>
-            <a:r>
-              <a:rPr sz="1200" b="1">
+                <a:spcPct val="110000"/>
+              </a:lnSpc>
+            </a:pPr>
+            <a:r>
+              <a:rPr sz="1000" b="1">
                 <a:solidFill>
                   <a:srgbClr val="087F5B"/>
                 </a:solidFill>
                 <a:latin typeface="Liberation Sans"/>
               </a:rPr>
-              <a:t>Every write is explicit · Every custody movement is public · Private state remains encrypted</a:t>
-            </a:r>
-          </a:p>
-        </p:txBody>
-      </p:sp>
-      <p:sp>
-        <p:nvSpPr>
-          <p:cNvPr id="41" name="TextBox 40"/>
+              <a:t>Public: custody + receipts
+Private: positions + winner</a:t>
+            </a:r>
+          </a:p>
+        </p:txBody>
+      </p:sp>
+      <p:sp>
+        <p:nvSpPr>
+          <p:cNvPr id="47" name="TextBox 46"/>
           <p:cNvSpPr txBox="1"/>
           <p:nvPr/>
         </p:nvSpPr>
@@ -9010,7 +9254,7 @@
                 </a:solidFill>
                 <a:latin typeface="Liberation Sans"/>
               </a:rPr>
-              <a:t>Chain, bytecode, vault, and custody bindings are checked before protocol writes.</a:t>
+              <a:t>Chain, bytecode, and custody bindings are checked before protocol writes.</a:t>
             </a:r>
           </a:p>
         </p:txBody>
@@ -9563,7 +9807,7 @@
                 </a:solidFill>
                 <a:latin typeface="Liberation Sans"/>
               </a:rPr>
-              <a:t>Deposit</a:t>
+              <a:t>Shield</a:t>
             </a:r>
           </a:p>
         </p:txBody>
@@ -9602,7 +9846,7 @@
                 </a:solidFill>
                 <a:latin typeface="Liberation Sans"/>
               </a:rPr>
-              <a:t>Public testnet USDC moves into custody; equal encrypted credit is derived on-chain.</a:t>
+              <a:t>Wrap test USDC into confidential cUSDC with Zama's official Sepolia wrapper.</a:t>
             </a:r>
           </a:p>
         </p:txBody>
@@ -9811,7 +10055,7 @@
                 </a:solidFill>
                 <a:latin typeface="Liberation Sans"/>
               </a:rPr>
-              <a:t>Prize round</a:t>
+              <a:t>Save</a:t>
             </a:r>
           </a:p>
         </p:txBody>
@@ -9850,7 +10094,7 @@
                 </a:solidFill>
                 <a:latin typeface="Liberation Sans"/>
               </a:rPr>
-              <a:t>Encrypted ticket weights enter homomorphic weighted selection.</a:t>
+              <a:t>Deposit an encrypted cUSDC amount; the pool credits only the token-returned result.</a:t>
             </a:r>
           </a:p>
         </p:txBody>
@@ -10059,7 +10303,7 @@
                 </a:solidFill>
                 <a:latin typeface="Liberation Sans"/>
               </a:rPr>
-              <a:t>Request</a:t>
+              <a:t>Prize round</a:t>
             </a:r>
           </a:p>
         </p:txBody>
@@ -10098,7 +10342,7 @@
                 </a:solidFill>
                 <a:latin typeface="Liberation Sans"/>
               </a:rPr>
-              <a:t>Encrypted sufficiency is evaluated and a request-bound handle is stored.</a:t>
+              <a:t>Fund or monitor the sponsor reserve, then run a KMS-verified encrypted draw.</a:t>
             </a:r>
           </a:p>
         </p:txBody>
@@ -10307,7 +10551,7 @@
                 </a:solidFill>
                 <a:latin typeface="Liberation Sans"/>
               </a:rPr>
-              <a:t>Finalize</a:t>
+              <a:t>Withdraw</a:t>
             </a:r>
           </a:p>
         </p:txBody>
@@ -10346,7 +10590,7 @@
                 </a:solidFill>
                 <a:latin typeface="Liberation Sans"/>
               </a:rPr>
-              <a:t>KMS proof is prepared; the requesting wallet signs the settlement transaction.</a:t>
+              <a:t>Submit an encrypted amount; accounting follows the token-returned transfer result.</a:t>
             </a:r>
           </a:p>
         </p:txBody>
@@ -10940,7 +11184,7 @@
                 </a:solidFill>
                 <a:latin typeface="Liberation Sans"/>
               </a:rPr>
-              <a:t>Encrypted deposit credit is derived from the transferred public amount.</a:t>
+              <a:t>Encrypted deposit credit is derived from the token-returned custody amount.</a:t>
             </a:r>
           </a:p>
         </p:txBody>
@@ -11147,7 +11391,7 @@
                 </a:solidFill>
                 <a:latin typeface="Liberation Sans"/>
               </a:rPr>
-              <a:t>Each draw consumes available yield so assets cannot fund repeated awards.</a:t>
+              <a:t>Each draw consumes verified sponsor funds so assets cannot fund repeated awards.</a:t>
             </a:r>
           </a:p>
         </p:txBody>
@@ -11354,7 +11598,7 @@
                 </a:solidFill>
                 <a:latin typeface="Liberation Sans"/>
               </a:rPr>
-              <a:t>Compounded prizes increase aggregate accounted obligations.</a:t>
+              <a:t>Winner credit enters both the encrypted position and aggregate at finalization.</a:t>
             </a:r>
           </a:p>
         </p:txBody>
@@ -11522,7 +11766,7 @@
                 </a:solidFill>
                 <a:latin typeface="Liberation Sans"/>
               </a:rPr>
-              <a:t>Anchored requests</a:t>
+              <a:t>Bound draw proofs</a:t>
             </a:r>
           </a:p>
         </p:txBody>
@@ -11561,7 +11805,7 @@
                 </a:solidFill>
                 <a:latin typeface="Liberation Sans"/>
               </a:rPr>
-              <a:t>The encrypted withdrawal handle is stored and bound to the requester.</a:t>
+              <a:t>KMS evidence must match the stored aggregate and reserve handles.</a:t>
             </a:r>
           </a:p>
         </p:txBody>
@@ -11729,7 +11973,7 @@
                 </a:solidFill>
                 <a:latin typeface="Liberation Sans"/>
               </a:rPr>
-              <a:t>Verifiable exit</a:t>
+              <a:t>Timeout recovery</a:t>
             </a:r>
           </a:p>
         </p:txBody>
@@ -11768,7 +12012,7 @@
                 </a:solidFill>
                 <a:latin typeface="Liberation Sans"/>
               </a:rPr>
-              <a:t>KMS signatures are checked on-chain; stale requests can cancel after 24 hours.</a:t>
+              <a:t>Anyone can release a stale draw lock after the 24-hour cancellation delay.</a:t>
             </a:r>
           </a:p>
         </p:txBody>
@@ -12155,7 +12399,7 @@
                 </a:solidFill>
                 <a:latin typeface="Liberation Sans"/>
               </a:rPr>
-              <a:t>A real 1 USDC Sepolia lifecycle—not a simulated receipt</a:t>
+              <a:t>A real 1 cUSDC Sepolia lifecycle—not a simulated receipt</a:t>
             </a:r>
           </a:p>
         </p:txBody>
@@ -12362,7 +12606,7 @@
                 </a:solidFill>
                 <a:latin typeface="Liberation Sans"/>
               </a:rPr>
-              <a:t>Deposit</a:t>
+              <a:t>cUSDC deposit</a:t>
             </a:r>
           </a:p>
         </p:txBody>
@@ -12411,7 +12655,7 @@
                 <a:latin typeface="Liberation Mono"/>
                 <a:hlinkClick r:id="rId2"/>
               </a:rPr>
-              <a:t>0x934340…8e2e</a:t>
+              <a:t>0x36f81f…fa87</a:t>
             </a:r>
           </a:p>
         </p:txBody>
@@ -12450,7 +12694,7 @@
                 </a:solidFill>
                 <a:latin typeface="Liberation Sans"/>
               </a:rPr>
-              <a:t>Custody +1 USDC</a:t>
+              <a:t>Encrypted position</a:t>
             </a:r>
           </a:p>
         </p:txBody>
@@ -12618,7 +12862,7 @@
                 </a:solidFill>
                 <a:latin typeface="Liberation Sans"/>
               </a:rPr>
-              <a:t>Withdrawal request</a:t>
+              <a:t>Direct withdrawal</a:t>
             </a:r>
           </a:p>
         </p:txBody>
@@ -12667,7 +12911,7 @@
                 <a:latin typeface="Liberation Mono"/>
                 <a:hlinkClick r:id="rId3"/>
               </a:rPr>
-              <a:t>0x31ae42…7a6b</a:t>
+              <a:t>0x8ee0e4…8429</a:t>
             </a:r>
           </a:p>
         </p:txBody>
@@ -12706,7 +12950,7 @@
                 </a:solidFill>
                 <a:latin typeface="Liberation Sans"/>
               </a:rPr>
-              <a:t>Handle anchored</a:t>
+              <a:t>Wallet restored</a:t>
             </a:r>
           </a:p>
         </p:txBody>
@@ -12874,7 +13118,7 @@
                 </a:solidFill>
                 <a:latin typeface="Liberation Sans"/>
               </a:rPr>
-              <a:t>KMS finalization</a:t>
+              <a:t>Sponsor reserve</a:t>
             </a:r>
           </a:p>
         </p:txBody>
@@ -12923,7 +13167,7 @@
                 <a:latin typeface="Liberation Mono"/>
                 <a:hlinkClick r:id="rId4"/>
               </a:rPr>
-              <a:t>0xc160a1…3878</a:t>
+              <a:t>0x07b797…7eaa</a:t>
             </a:r>
           </a:p>
         </p:txBody>
@@ -12962,7 +13206,7 @@
                 </a:solidFill>
                 <a:latin typeface="Liberation Sans"/>
               </a:rPr>
-              <a:t>Wallet restored</a:t>
+              <a:t>Encrypted prize funds</a:t>
             </a:r>
           </a:p>
         </p:txBody>
@@ -13046,7 +13290,7 @@
                 </a:solidFill>
                 <a:latin typeface="Liberation Sans"/>
               </a:rPr>
-              <a:t>Final state: wallet 20 USDC · pool custody 0 · accounted principal 0</a:t>
+              <a:t>Round trip restored 10 cUSDC · later sponsor funding moved 1 cUSDC into reserve</a:t>
             </a:r>
           </a:p>
         </p:txBody>
@@ -13433,7 +13677,7 @@
                 </a:solidFill>
                 <a:latin typeface="Liberation Sans"/>
               </a:rPr>
-              <a:t>113 automated tests—and durable live infrastructure</a:t>
+              <a:t>Reproducible tests—and durable live infrastructure</a:t>
             </a:r>
           </a:p>
         </p:txBody>
@@ -13511,13 +13755,13 @@
               </a:lnSpc>
             </a:pPr>
             <a:r>
-              <a:rPr sz="5200" b="1">
+              <a:rPr sz="4800" b="1">
                 <a:solidFill>
                   <a:srgbClr val="FFFFFF"/>
                 </a:solidFill>
                 <a:latin typeface="Liberation Sans"/>
               </a:rPr>
-              <a:t>113</a:t>
+              <a:t>FULL</a:t>
             </a:r>
           </a:p>
         </p:txBody>
@@ -13556,7 +13800,7 @@
                 </a:solidFill>
                 <a:latin typeface="Liberation Mono"/>
               </a:rPr>
-              <a:t>PASSING TESTS</a:t>
+              <a:t>VALIDATION SUITE</a:t>
             </a:r>
           </a:p>
         </p:txBody>
@@ -13569,8 +13813,8 @@
         </p:nvSpPr>
         <p:spPr>
           <a:xfrm>
-            <a:off x="914400" y="4251960"/>
-            <a:ext cx="3200400" cy="731520"/>
+            <a:off x="914400" y="4187952"/>
+            <a:ext cx="3200400" cy="914400"/>
           </a:xfrm>
           <a:prstGeom prst="rect">
             <a:avLst/>
@@ -13589,14 +13833,14 @@
               </a:lnSpc>
             </a:pPr>
             <a:r>
-              <a:rPr sz="1400" b="0">
+              <a:rPr sz="1300" b="0">
                 <a:solidFill>
                   <a:srgbClr val="FFFFFF"/>
                 </a:solidFill>
                 <a:latin typeface="Liberation Sans"/>
               </a:rPr>
-              <a:t>51 Foundry · 32 backend
-2 client · 28 frontend</a:t>
+              <a:t>Foundry contracts · backend API/indexer
+client encryption · frontend UX</a:t>
             </a:r>
           </a:p>
         </p:txBody>
@@ -13926,7 +14170,7 @@
                 </a:solidFill>
                 <a:latin typeface="Liberation Sans"/>
               </a:rPr>
-              <a:t>Node relayer/indexer</a:t>
+              <a:t>Node indexer/API</a:t>
             </a:r>
           </a:p>
         </p:txBody>

</xml_diff>

<commit_message>
feat(ops): verify complete Sepolia prize lifecycle
</commit_message>
<xml_diff>
--- a/docs/showcase/presentation/CipherPool-Presentation.pptx
+++ b/docs/showcase/presentation/CipherPool-Presentation.pptx
@@ -4634,11 +4634,11 @@
                 </a:solidFill>
                 <a:latin typeface="Liberation Mono"/>
               </a:rPr>
-              <a:t>0xE47eF44E
-BB804A50
-7173BEFa
-5beb2325
-aA7451AD</a:t>
+              <a:t>0x9c939b82
+a1B23b77
+746f934A
+1Ff2b9a5
+bCf191e0</a:t>
             </a:r>
           </a:p>
         </p:txBody>
@@ -12399,7 +12399,7 @@
                 </a:solidFill>
                 <a:latin typeface="Liberation Sans"/>
               </a:rPr>
-              <a:t>A real 1 cUSDC Sepolia lifecycle—not a simulated receipt</a:t>
+              <a:t>A complete live prize round—not a simulated receipt</a:t>
             </a:r>
           </a:p>
         </p:txBody>
@@ -12655,7 +12655,7 @@
                 <a:latin typeface="Liberation Mono"/>
                 <a:hlinkClick r:id="rId2"/>
               </a:rPr>
-              <a:t>0x36f81f…fa87</a:t>
+              <a:t>0xe36db7…b39f</a:t>
             </a:r>
           </a:p>
         </p:txBody>
@@ -12862,7 +12862,7 @@
                 </a:solidFill>
                 <a:latin typeface="Liberation Sans"/>
               </a:rPr>
-              <a:t>Direct withdrawal</a:t>
+              <a:t>KMS draw</a:t>
             </a:r>
           </a:p>
         </p:txBody>
@@ -12911,7 +12911,7 @@
                 <a:latin typeface="Liberation Mono"/>
                 <a:hlinkClick r:id="rId3"/>
               </a:rPr>
-              <a:t>0x8ee0e4…8429</a:t>
+              <a:t>0x504862…ce6c</a:t>
             </a:r>
           </a:p>
         </p:txBody>
@@ -12950,7 +12950,7 @@
                 </a:solidFill>
                 <a:latin typeface="Liberation Sans"/>
               </a:rPr>
-              <a:t>Wallet restored</a:t>
+              <a:t>Draw 1 finalized</a:t>
             </a:r>
           </a:p>
         </p:txBody>
@@ -13118,7 +13118,7 @@
                 </a:solidFill>
                 <a:latin typeface="Liberation Sans"/>
               </a:rPr>
-              <a:t>Sponsor reserve</a:t>
+              <a:t>Private claim</a:t>
             </a:r>
           </a:p>
         </p:txBody>
@@ -13167,7 +13167,7 @@
                 <a:latin typeface="Liberation Mono"/>
                 <a:hlinkClick r:id="rId4"/>
               </a:rPr>
-              <a:t>0x07b797…7eaa</a:t>
+              <a:t>0x5763be…c969</a:t>
             </a:r>
           </a:p>
         </p:txBody>
@@ -13206,7 +13206,7 @@
                 </a:solidFill>
                 <a:latin typeface="Liberation Sans"/>
               </a:rPr>
-              <a:t>Encrypted prize funds</a:t>
+              <a:t>Ordinary withdrawal</a:t>
             </a:r>
           </a:p>
         </p:txBody>
@@ -13290,7 +13290,7 @@
                 </a:solidFill>
                 <a:latin typeface="Liberation Sans"/>
               </a:rPr>
-              <a:t>Round trip restored 10 cUSDC · later sponsor funding moved 1 cUSDC into reserve</a:t>
+              <a:t>Deposit → KMS draw → private claim → principal withdrawal · all confirmed</a:t>
             </a:r>
           </a:p>
         </p:txBody>

</xml_diff>